<commit_message>
feat: implement CueDeck web-based presentation recording interface and supporting documentation
</commit_message>
<xml_diff>
--- a/Sem1_PLSQL_Unit4_Packages.pptx
+++ b/Sem1_PLSQL_Unit4_Packages.pptx
@@ -4,6 +4,9 @@
   <p:sldMasterIdLst>
     <p:sldMasterId id="2147483648" r:id="rId1"/>
   </p:sldMasterIdLst>
+  <p:notesMasterIdLst>
+    <p:notesMasterId r:id="rId8"/>
+  </p:notesMasterIdLst>
   <p:sldIdLst>
     <p:sldId id="256" r:id="rId2"/>
     <p:sldId id="257" r:id="rId3"/>
@@ -12,9 +15,6 @@
     <p:sldId id="260" r:id="rId6"/>
     <p:sldId id="261" r:id="rId7"/>
   </p:sldIdLst>
-  <p:notesMasterIdLst>
-    <p:notesMasterId r:id="rId8"/>
-  </p:notesMasterIdLst>
   <p:sldSz cx="12192000" cy="6858000"/>
   <p:notesSz cx="6858000" cy="12192000"/>
   <p:defaultTextStyle>
@@ -109,6 +109,11 @@
       </a:defRPr>
     </a:lvl9pPr>
   </p:defaultTextStyle>
+  <p:extLst>
+    <p:ext uri="{EFAFB233-063F-42B5-8137-9DF3F51BA10A}">
+      <p15:sldGuideLst xmlns:p15="http://schemas.microsoft.com/office/powerpoint/2012/main"/>
+    </p:ext>
+  </p:extLst>
 </p:presentation>
 </file>
 
@@ -134,234 +139,10 @@
           <a:chExt cx="0" cy="0"/>
         </a:xfrm>
       </p:grpSpPr>
-      <p:sp>
-        <p:nvSpPr>
-          <p:cNvPr id="2" name="Header Placeholder 1"/>
-          <p:cNvSpPr>
-            <a:spLocks noGrp="1"/>
-          </p:cNvSpPr>
-          <p:nvPr>
-            <p:ph type="hdr" sz="quarter"/>
-          </p:nvPr>
-        </p:nvSpPr>
-        <p:spPr>
-          <a:xfrm>
-            <a:off x="0" y="0"/>
-            <a:ext cx="2971800" cy="458788"/>
-          </a:xfrm>
-          <a:prstGeom prst="rect">
-            <a:avLst/>
-          </a:prstGeom>
-        </p:spPr>
-        <p:txBody>
-          <a:bodyPr vert="horz" lIns="91440" tIns="45720" rIns="91440" bIns="45720" rtlCol="0"/>
-          <a:lstStyle>
-            <a:lvl1pPr algn="l">
-              <a:defRPr sz="1200"/>
-            </a:lvl1pPr>
-          </a:lstStyle>
-          <a:p>
-            <a:endParaRPr lang="en-US"/>
-          </a:p>
-        </p:txBody>
-      </p:sp>
-      <p:sp>
-        <p:nvSpPr>
-          <p:cNvPr id="3" name="Date Placeholder 2"/>
-          <p:cNvSpPr>
-            <a:spLocks noGrp="1"/>
-          </p:cNvSpPr>
-          <p:nvPr>
-            <p:ph type="dt" idx="1"/>
-          </p:nvPr>
-        </p:nvSpPr>
-        <p:spPr>
-          <a:xfrm>
-            <a:off x="3884613" y="0"/>
-            <a:ext cx="2971800" cy="458788"/>
-          </a:xfrm>
-          <a:prstGeom prst="rect">
-            <a:avLst/>
-          </a:prstGeom>
-        </p:spPr>
-        <p:txBody>
-          <a:bodyPr vert="horz" lIns="91440" tIns="45720" rIns="91440" bIns="45720" rtlCol="0"/>
-          <a:lstStyle>
-            <a:lvl1pPr algn="r">
-              <a:defRPr sz="1200"/>
-            </a:lvl1pPr>
-          </a:lstStyle>
-          <a:p>
-            <a:fld id="{5282F153-3F37-0F45-9E97-73ACFA13230C}" type="datetimeFigureOut">
-              <a:rPr lang="en-US"/>
-              <a:t>7/23/19</a:t>
-            </a:fld>
-            <a:endParaRPr lang="en-US"/>
-          </a:p>
-        </p:txBody>
-      </p:sp>
-      <p:sp>
-        <p:nvSpPr>
-          <p:cNvPr id="4" name="Slide Image Placeholder 3"/>
-          <p:cNvSpPr>
-            <a:spLocks noGrp="1" noRot="1" noChangeAspect="1"/>
-          </p:cNvSpPr>
-          <p:nvPr>
-            <p:ph type="sldImg" idx="2"/>
-          </p:nvPr>
-        </p:nvSpPr>
-        <p:spPr>
-          <a:xfrm>
-            <a:off x="685800" y="1143000"/>
-            <a:ext cx="5486400" cy="3086100"/>
-          </a:xfrm>
-          <a:prstGeom prst="rect">
-            <a:avLst/>
-          </a:prstGeom>
-          <a:noFill/>
-          <a:ln w="12700">
-            <a:solidFill>
-              <a:prstClr val="black"/>
-            </a:solidFill>
-          </a:ln>
-        </p:spPr>
-        <p:txBody>
-          <a:bodyPr vert="horz" lIns="91440" tIns="45720" rIns="91440" bIns="45720" rtlCol="0" anchor="ctr"/>
-          <a:lstStyle/>
-          <a:p>
-            <a:endParaRPr lang="en-US"/>
-          </a:p>
-        </p:txBody>
-      </p:sp>
-      <p:sp>
-        <p:nvSpPr>
-          <p:cNvPr id="5" name="Notes Placeholder 4"/>
-          <p:cNvSpPr>
-            <a:spLocks noGrp="1"/>
-          </p:cNvSpPr>
-          <p:nvPr>
-            <p:ph type="body" sz="quarter" idx="3"/>
-          </p:nvPr>
-        </p:nvSpPr>
-        <p:spPr>
-          <a:xfrm>
-            <a:off x="685800" y="4400550"/>
-            <a:ext cx="5486400" cy="3600450"/>
-          </a:xfrm>
-          <a:prstGeom prst="rect">
-            <a:avLst/>
-          </a:prstGeom>
-        </p:spPr>
-        <p:txBody>
-          <a:bodyPr vert="horz" lIns="91440" tIns="45720" rIns="91440" bIns="45720" rtlCol="0"/>
-          <a:lstStyle/>
-          <a:p>
-            <a:pPr lvl="0"/>
-            <a:r>
-              <a:rPr lang="en-US"/>
-              <a:t>Click to edit Master text styles</a:t>
-            </a:r>
-          </a:p>
-          <a:p>
-            <a:pPr lvl="1"/>
-            <a:r>
-              <a:rPr lang="en-US"/>
-              <a:t>Second level</a:t>
-            </a:r>
-          </a:p>
-          <a:p>
-            <a:pPr lvl="2"/>
-            <a:r>
-              <a:rPr lang="en-US"/>
-              <a:t>Third level</a:t>
-            </a:r>
-          </a:p>
-          <a:p>
-            <a:pPr lvl="3"/>
-            <a:r>
-              <a:rPr lang="en-US"/>
-              <a:t>Fourth level</a:t>
-            </a:r>
-          </a:p>
-          <a:p>
-            <a:pPr lvl="4"/>
-            <a:r>
-              <a:rPr lang="en-US"/>
-              <a:t>Fifth level</a:t>
-            </a:r>
-          </a:p>
-        </p:txBody>
-      </p:sp>
-      <p:sp>
-        <p:nvSpPr>
-          <p:cNvPr id="6" name="Footer Placeholder 5"/>
-          <p:cNvSpPr>
-            <a:spLocks noGrp="1"/>
-          </p:cNvSpPr>
-          <p:nvPr>
-            <p:ph type="ftr" sz="quarter" idx="4"/>
-          </p:nvPr>
-        </p:nvSpPr>
-        <p:spPr>
-          <a:xfrm>
-            <a:off x="0" y="8685213"/>
-            <a:ext cx="2971800" cy="458787"/>
-          </a:xfrm>
-          <a:prstGeom prst="rect">
-            <a:avLst/>
-          </a:prstGeom>
-        </p:spPr>
-        <p:txBody>
-          <a:bodyPr vert="horz" lIns="91440" tIns="45720" rIns="91440" bIns="45720" rtlCol="0" anchor="b"/>
-          <a:lstStyle>
-            <a:lvl1pPr algn="l">
-              <a:defRPr sz="1200"/>
-            </a:lvl1pPr>
-          </a:lstStyle>
-          <a:p>
-            <a:endParaRPr lang="en-US"/>
-          </a:p>
-        </p:txBody>
-      </p:sp>
-      <p:sp>
-        <p:nvSpPr>
-          <p:cNvPr id="7" name="Slide Number Placeholder 6"/>
-          <p:cNvSpPr>
-            <a:spLocks noGrp="1"/>
-          </p:cNvSpPr>
-          <p:nvPr>
-            <p:ph type="sldNum" sz="quarter" idx="5"/>
-          </p:nvPr>
-        </p:nvSpPr>
-        <p:spPr>
-          <a:xfrm>
-            <a:off x="3884613" y="8685213"/>
-            <a:ext cx="2971800" cy="458787"/>
-          </a:xfrm>
-          <a:prstGeom prst="rect">
-            <a:avLst/>
-          </a:prstGeom>
-        </p:spPr>
-        <p:txBody>
-          <a:bodyPr vert="horz" lIns="91440" tIns="45720" rIns="91440" bIns="45720" rtlCol="0" anchor="b"/>
-          <a:lstStyle>
-            <a:lvl1pPr algn="r">
-              <a:defRPr sz="1200"/>
-            </a:lvl1pPr>
-          </a:lstStyle>
-          <a:p>
-            <a:fld id="{CE5E9CC1-C706-0F49-92D6-E571CC5EEA8F}" type="slidenum">
-              <a:rPr lang="en-US"/>
-              <a:t>‹#›</a:t>
-            </a:fld>
-            <a:endParaRPr lang="en-US"/>
-          </a:p>
-        </p:txBody>
-      </p:sp>
     </p:spTree>
     <p:extLst>
       <p:ext uri="{BB962C8B-B14F-4D97-AF65-F5344CB8AC3E}">
-        <p14:creationId xmlns:p14="http://schemas.microsoft.com/office/powerpoint/2010/main" val="1024086991"/>
+        <p14:creationId xmlns:p14="http://schemas.microsoft.com/office/powerpoint/2010/main" val="984629979"/>
       </p:ext>
     </p:extLst>
   </p:cSld>
@@ -505,10 +286,6 @@
           <a:bodyPr/>
           <a:lstStyle/>
           <a:p>
-            <a:r>
-              <a:rPr lang="en-US" dirty="0"/>
-              <a:t/>
-            </a:r>
             <a:endParaRPr lang="en-US" dirty="0"/>
           </a:p>
         </p:txBody>
@@ -599,7 +376,6 @@
 A package is a container that groups related database variables, cursors, types, and subprograms. It has a two-part design: the Specification and the Body.
 The Package Specification acts like a Java Interface or C++ header. It defines the public API. The Package Body implements that API. Because they are compiled separately, you can modify code inside the body without invalidating other database procedures that call the package specification. This is critical for maintaining large enterprise databases.</a:t>
             </a:r>
-            <a:endParaRPr lang="en-US" dirty="0"/>
           </a:p>
         </p:txBody>
       </p:sp>
@@ -690,7 +466,6 @@
 1. Definer Rights (AUTHID DEFINER): The default. The package runs using the permissions of its owner. This enables secure data encapsulation. Users can write to table data via procedures without having direct privileges on the tables.
 2. Invoker Rights (AUTHID CURRENT_USER): The package runs with the permissions of the user calling it. References to table names resolve dynamically to the caller's schema, making it ideal for shared database utility libraries.</a:t>
             </a:r>
-            <a:endParaRPr lang="en-US" dirty="0"/>
           </a:p>
         </p:txBody>
       </p:sp>
@@ -780,7 +555,6 @@
 Oracle maintains objects and source code inside the catalog views. The USER_OBJECTS view shows whether packages are VALID or INVALID.
 When a package specification is modified, Oracle marks dependent objects as invalid. It uses two validation methods: Timestamp validation (re-compiles all dependencies on time changes, which can trigger large rebuild cascades) and Signature validation (only re-compiles if parameter signatures, types, or return arguments are altered). Signature validation is typically preferred in production environments to minimize rebuild outages.</a:t>
             </a:r>
-            <a:endParaRPr lang="en-US" dirty="0"/>
           </a:p>
         </p:txBody>
       </p:sp>
@@ -869,7 +643,6 @@
               <a:t>Slide 5 – Applications
 PL/SQL packages organize code, manage state across user sessions, cache constants, and hide implementation details. They are a core architectural component of enterprise Oracle applications.</a:t>
             </a:r>
-            <a:endParaRPr lang="en-US" dirty="0"/>
           </a:p>
         </p:txBody>
       </p:sp>
@@ -953,10 +726,6 @@
           <a:bodyPr/>
           <a:lstStyle/>
           <a:p>
-            <a:r>
-              <a:rPr lang="en-US" dirty="0"/>
-              <a:t/>
-            </a:r>
             <a:endParaRPr lang="en-US" dirty="0"/>
           </a:p>
         </p:txBody>
@@ -1030,6 +799,11 @@
 <file path=ppt/slideMasters/slideMaster1.xml><?xml version="1.0" encoding="utf-8"?>
 <p:sldMaster xmlns:a="http://schemas.openxmlformats.org/drawingml/2006/main" xmlns:r="http://schemas.openxmlformats.org/officeDocument/2006/relationships" xmlns:p="http://schemas.openxmlformats.org/presentationml/2006/main">
   <p:cSld>
+    <p:bg>
+      <p:bgRef idx="1001">
+        <a:schemeClr val="bg1"/>
+      </p:bgRef>
+    </p:bg>
     <p:spTree>
       <p:nvGrpSpPr>
         <p:cNvPr id="1" name=""/>
@@ -1312,6 +1086,7 @@
         <a:solidFill>
           <a:srgbClr val="FFFFFF"/>
         </a:solidFill>
+        <a:effectLst/>
       </p:bgPr>
     </p:bg>
     <p:spTree>
@@ -1574,7 +1349,7 @@
           <a:bodyPr wrap="square" lIns="0" tIns="0" rIns="0" bIns="0" rtlCol="0" anchor="ctr"/>
           <a:lstStyle/>
           <a:p>
-            <a:pPr algn="ctr" indent="0" marL="0">
+            <a:pPr marL="0" indent="0" algn="ctr">
               <a:buNone/>
             </a:pPr>
             <a:r>
@@ -1594,14 +1369,14 @@
       </p:sp>
       <p:pic>
         <p:nvPicPr>
-          <p:cNvPr id="12" name="Image 0" descr="preencoded.png">    </p:cNvPr>
+          <p:cNvPr id="12" name="Image 0" descr="preencoded.png"/>
           <p:cNvPicPr>
             <a:picLocks noChangeAspect="1"/>
           </p:cNvPicPr>
           <p:nvPr/>
         </p:nvPicPr>
         <p:blipFill>
-          <a:blip r:embed="rId1"/>
+          <a:blip r:embed="rId3"/>
           <a:stretch>
             <a:fillRect/>
           </a:stretch>
@@ -1637,7 +1412,7 @@
           <a:bodyPr wrap="square" rtlCol="0" anchor="ctr"/>
           <a:lstStyle/>
           <a:p>
-            <a:pPr algn="ctr" indent="0" marL="0">
+            <a:pPr marL="0" indent="0" algn="ctr">
               <a:buNone/>
             </a:pPr>
             <a:r>
@@ -1701,7 +1476,7 @@
           <a:bodyPr wrap="square" lIns="0" tIns="0" rIns="0" bIns="0" rtlCol="0" anchor="ctr"/>
           <a:lstStyle/>
           <a:p>
-            <a:pPr algn="ctr" indent="0" marL="0">
+            <a:pPr marL="0" indent="0" algn="ctr">
               <a:buNone/>
             </a:pPr>
             <a:r>
@@ -1740,7 +1515,7 @@
           <a:bodyPr wrap="square" rtlCol="0" anchor="ctr"/>
           <a:lstStyle/>
           <a:p>
-            <a:pPr algn="ctr" indent="0" marL="0">
+            <a:pPr marL="0" indent="0" algn="ctr">
               <a:buNone/>
             </a:pPr>
             <a:r>
@@ -1779,7 +1554,7 @@
           <a:bodyPr wrap="square" rtlCol="0" anchor="ctr"/>
           <a:lstStyle/>
           <a:p>
-            <a:pPr indent="0" marL="0">
+            <a:pPr marL="0" indent="0">
               <a:buNone/>
             </a:pPr>
             <a:r>
@@ -1791,7 +1566,29 @@
                 <a:ea typeface="Arial" pitchFamily="34" charset="-122"/>
                 <a:cs typeface="Arial" pitchFamily="34" charset="-120"/>
               </a:rPr>
-              <a:t>NAME :   SRinivas Rao Tammireddy</a:t>
+              <a:t>NAME </a:t>
+            </a:r>
+            <a:r>
+              <a:rPr lang="en-US" sz="1300">
+                <a:solidFill>
+                  <a:srgbClr val="000000"/>
+                </a:solidFill>
+                <a:latin typeface="Arial" pitchFamily="34" charset="0"/>
+                <a:ea typeface="Arial" pitchFamily="34" charset="-122"/>
+                <a:cs typeface="Arial" pitchFamily="34" charset="-120"/>
+              </a:rPr>
+              <a:t>:   Srinivas </a:t>
+            </a:r>
+            <a:r>
+              <a:rPr lang="en-US" sz="1300" dirty="0">
+                <a:solidFill>
+                  <a:srgbClr val="000000"/>
+                </a:solidFill>
+                <a:latin typeface="Arial" pitchFamily="34" charset="0"/>
+                <a:ea typeface="Arial" pitchFamily="34" charset="-122"/>
+                <a:cs typeface="Arial" pitchFamily="34" charset="-120"/>
+              </a:rPr>
+              <a:t>Rao Tammireddy</a:t>
             </a:r>
             <a:endParaRPr lang="en-US" sz="1300" dirty="0"/>
           </a:p>
@@ -1818,7 +1615,7 @@
           <a:bodyPr wrap="square" rtlCol="0" anchor="ctr"/>
           <a:lstStyle/>
           <a:p>
-            <a:pPr indent="0" marL="0">
+            <a:pPr marL="0" indent="0">
               <a:buNone/>
             </a:pPr>
             <a:r>
@@ -1857,7 +1654,7 @@
           <a:bodyPr wrap="square" rtlCol="0" anchor="ctr"/>
           <a:lstStyle/>
           <a:p>
-            <a:pPr indent="0" marL="0">
+            <a:pPr marL="0" indent="0">
               <a:buNone/>
             </a:pPr>
             <a:r>
@@ -1896,7 +1693,7 @@
           <a:bodyPr wrap="square" rtlCol="0" anchor="ctr"/>
           <a:lstStyle/>
           <a:p>
-            <a:pPr indent="0" marL="0">
+            <a:pPr marL="0" indent="0">
               <a:buNone/>
             </a:pPr>
             <a:r>
@@ -1935,7 +1732,7 @@
           <a:bodyPr wrap="square" rtlCol="0" anchor="ctr"/>
           <a:lstStyle/>
           <a:p>
-            <a:pPr algn="ctr" indent="0" marL="0">
+            <a:pPr marL="0" indent="0" algn="ctr">
               <a:buNone/>
             </a:pPr>
             <a:r>
@@ -1969,6 +1766,7 @@
         <a:solidFill>
           <a:srgbClr val="FFFFFF"/>
         </a:solidFill>
+        <a:effectLst/>
       </p:bgPr>
     </p:bg>
     <p:spTree>
@@ -2231,7 +2029,7 @@
           <a:bodyPr wrap="square" lIns="0" tIns="0" rIns="0" bIns="0" rtlCol="0" anchor="ctr"/>
           <a:lstStyle/>
           <a:p>
-            <a:pPr algn="ctr" indent="0" marL="0">
+            <a:pPr marL="0" indent="0" algn="ctr">
               <a:buNone/>
             </a:pPr>
             <a:r>
@@ -2251,14 +2049,14 @@
       </p:sp>
       <p:pic>
         <p:nvPicPr>
-          <p:cNvPr id="12" name="Image 0" descr="preencoded.png">    </p:cNvPr>
+          <p:cNvPr id="12" name="Image 0" descr="preencoded.png"/>
           <p:cNvPicPr>
             <a:picLocks noChangeAspect="1"/>
           </p:cNvPicPr>
           <p:nvPr/>
         </p:nvPicPr>
         <p:blipFill>
-          <a:blip r:embed="rId1"/>
+          <a:blip r:embed="rId3"/>
           <a:stretch>
             <a:fillRect/>
           </a:stretch>
@@ -2294,7 +2092,7 @@
           <a:bodyPr wrap="square" rtlCol="0" anchor="ctr"/>
           <a:lstStyle/>
           <a:p>
-            <a:pPr indent="0" marL="0">
+            <a:pPr marL="0" indent="0">
               <a:buNone/>
             </a:pPr>
             <a:r>
@@ -2358,7 +2156,7 @@
           <a:bodyPr wrap="square" rtlCol="0" anchor="ctr"/>
           <a:lstStyle/>
           <a:p>
-            <a:pPr indent="0" marL="0">
+            <a:pPr marL="0" indent="0">
               <a:buNone/>
             </a:pPr>
             <a:r>
@@ -2372,9 +2170,6 @@
               </a:rPr>
               <a:t>A PL/SQL Package </a:t>
             </a:r>
-            <a:pPr indent="0" marL="0">
-              <a:buNone/>
-            </a:pPr>
             <a:r>
               <a:rPr lang="en-US" sz="1400" dirty="0">
                 <a:solidFill>
@@ -2438,7 +2233,7 @@
           <a:bodyPr wrap="square" lIns="0" tIns="0" rIns="0" bIns="0" rtlCol="0" anchor="ctr"/>
           <a:lstStyle/>
           <a:p>
-            <a:pPr indent="0" marL="0">
+            <a:pPr marL="0" indent="0">
               <a:buNone/>
             </a:pPr>
             <a:r>
@@ -2477,7 +2272,7 @@
           <a:bodyPr wrap="square" lIns="0" tIns="0" rIns="0" bIns="0" rtlCol="0" anchor="ctr"/>
           <a:lstStyle/>
           <a:p>
-            <a:pPr indent="0" marL="0">
+            <a:pPr marL="0" indent="0">
               <a:buNone/>
             </a:pPr>
             <a:r>
@@ -2491,9 +2286,6 @@
               </a:rPr>
               <a:t>1. Package Specification (Spec):</a:t>
             </a:r>
-            <a:pPr indent="0" marL="0">
-              <a:buNone/>
-            </a:pPr>
             <a:r>
               <a:rPr lang="en-US" sz="1300" dirty="0">
                 <a:solidFill>
@@ -2508,7 +2300,7 @@
             <a:endParaRPr lang="en-US" sz="1300" dirty="0"/>
           </a:p>
           <a:p>
-            <a:pPr indent="0" marL="0">
+            <a:pPr marL="0" indent="0">
               <a:buNone/>
             </a:pPr>
             <a:r>
@@ -2522,9 +2314,6 @@
               </a:rPr>
               <a:t>2. Package Body:</a:t>
             </a:r>
-            <a:pPr indent="0" marL="0">
-              <a:buNone/>
-            </a:pPr>
             <a:r>
               <a:rPr lang="en-US" sz="1300" dirty="0">
                 <a:solidFill>
@@ -2539,7 +2328,7 @@
             <a:endParaRPr lang="en-US" sz="1300" dirty="0"/>
           </a:p>
           <a:p>
-            <a:pPr indent="0" marL="0">
+            <a:pPr marL="0" indent="0">
               <a:buNone/>
             </a:pPr>
             <a:r>
@@ -2553,9 +2342,6 @@
               </a:rPr>
               <a:t>• Separate Compilation:</a:t>
             </a:r>
-            <a:pPr indent="0" marL="0">
-              <a:buNone/>
-            </a:pPr>
             <a:r>
               <a:rPr lang="en-US" sz="1300" dirty="0">
                 <a:solidFill>
@@ -2619,7 +2405,7 @@
           <a:bodyPr wrap="square" lIns="0" tIns="0" rIns="0" bIns="0" rtlCol="0" anchor="ctr"/>
           <a:lstStyle/>
           <a:p>
-            <a:pPr indent="0" marL="0">
+            <a:pPr marL="0" indent="0">
               <a:buNone/>
             </a:pPr>
             <a:r>
@@ -2658,7 +2444,7 @@
           <a:bodyPr wrap="square" lIns="0" tIns="0" rIns="0" bIns="0" rtlCol="0" anchor="ctr"/>
           <a:lstStyle/>
           <a:p>
-            <a:pPr indent="0" marL="0">
+            <a:pPr marL="0" indent="0">
               <a:buNone/>
             </a:pPr>
             <a:r>
@@ -2672,9 +2458,6 @@
               </a:rPr>
               <a:t>• Modular Development:</a:t>
             </a:r>
-            <a:pPr indent="0" marL="0">
-              <a:buNone/>
-            </a:pPr>
             <a:r>
               <a:rPr lang="en-US" sz="1300" dirty="0">
                 <a:solidFill>
@@ -2689,7 +2472,7 @@
             <a:endParaRPr lang="en-US" sz="1300" dirty="0"/>
           </a:p>
           <a:p>
-            <a:pPr indent="0" marL="0">
+            <a:pPr marL="0" indent="0">
               <a:buNone/>
             </a:pPr>
             <a:r>
@@ -2703,9 +2486,6 @@
               </a:rPr>
               <a:t>• Encapsulation (Information Hiding):</a:t>
             </a:r>
-            <a:pPr indent="0" marL="0">
-              <a:buNone/>
-            </a:pPr>
             <a:r>
               <a:rPr lang="en-US" sz="1300" dirty="0">
                 <a:solidFill>
@@ -2720,7 +2500,7 @@
             <a:endParaRPr lang="en-US" sz="1300" dirty="0"/>
           </a:p>
           <a:p>
-            <a:pPr indent="0" marL="0">
+            <a:pPr marL="0" indent="0">
               <a:buNone/>
             </a:pPr>
             <a:r>
@@ -2734,9 +2514,6 @@
               </a:rPr>
               <a:t>• Session Persistent State:</a:t>
             </a:r>
-            <a:pPr indent="0" marL="0">
-              <a:buNone/>
-            </a:pPr>
             <a:r>
               <a:rPr lang="en-US" sz="1300" dirty="0">
                 <a:solidFill>
@@ -2751,7 +2528,7 @@
             <a:endParaRPr lang="en-US" sz="1300" dirty="0"/>
           </a:p>
           <a:p>
-            <a:pPr indent="0" marL="0">
+            <a:pPr marL="0" indent="0">
               <a:buNone/>
             </a:pPr>
             <a:r>
@@ -2765,9 +2542,6 @@
               </a:rPr>
               <a:t>• High Performance:</a:t>
             </a:r>
-            <a:pPr indent="0" marL="0">
-              <a:buNone/>
-            </a:pPr>
             <a:r>
               <a:rPr lang="en-US" sz="1300" dirty="0">
                 <a:solidFill>
@@ -2799,6 +2573,7 @@
         <a:solidFill>
           <a:srgbClr val="FFFFFF"/>
         </a:solidFill>
+        <a:effectLst/>
       </p:bgPr>
     </p:bg>
     <p:spTree>
@@ -3061,7 +2836,7 @@
           <a:bodyPr wrap="square" lIns="0" tIns="0" rIns="0" bIns="0" rtlCol="0" anchor="ctr"/>
           <a:lstStyle/>
           <a:p>
-            <a:pPr algn="ctr" indent="0" marL="0">
+            <a:pPr marL="0" indent="0" algn="ctr">
               <a:buNone/>
             </a:pPr>
             <a:r>
@@ -3081,14 +2856,14 @@
       </p:sp>
       <p:pic>
         <p:nvPicPr>
-          <p:cNvPr id="12" name="Image 0" descr="preencoded.png">    </p:cNvPr>
+          <p:cNvPr id="12" name="Image 0" descr="preencoded.png"/>
           <p:cNvPicPr>
             <a:picLocks noChangeAspect="1"/>
           </p:cNvPicPr>
           <p:nvPr/>
         </p:nvPicPr>
         <p:blipFill>
-          <a:blip r:embed="rId1"/>
+          <a:blip r:embed="rId3"/>
           <a:stretch>
             <a:fillRect/>
           </a:stretch>
@@ -3124,7 +2899,7 @@
           <a:bodyPr wrap="square" rtlCol="0" anchor="ctr"/>
           <a:lstStyle/>
           <a:p>
-            <a:pPr indent="0" marL="0">
+            <a:pPr marL="0" indent="0">
               <a:buNone/>
             </a:pPr>
             <a:r>
@@ -3188,7 +2963,7 @@
           <a:bodyPr wrap="square" rtlCol="0" anchor="ctr"/>
           <a:lstStyle/>
           <a:p>
-            <a:pPr indent="0" marL="0">
+            <a:pPr marL="0" indent="0">
               <a:buNone/>
             </a:pPr>
             <a:r>
@@ -3254,7 +3029,7 @@
           <a:bodyPr wrap="square" lIns="0" tIns="0" rIns="0" bIns="0" rtlCol="0" anchor="ctr"/>
           <a:lstStyle/>
           <a:p>
-            <a:pPr indent="0" marL="0">
+            <a:pPr marL="0" indent="0">
               <a:buNone/>
             </a:pPr>
             <a:r>
@@ -3293,7 +3068,7 @@
           <a:bodyPr wrap="square" lIns="0" tIns="0" rIns="0" bIns="0" rtlCol="0" anchor="ctr"/>
           <a:lstStyle/>
           <a:p>
-            <a:pPr indent="0" marL="0">
+            <a:pPr marL="0" indent="0">
               <a:buNone/>
             </a:pPr>
             <a:r>
@@ -3307,9 +3082,6 @@
               </a:rPr>
               <a:t>• Default Privilege Behavior:</a:t>
             </a:r>
-            <a:pPr indent="0" marL="0">
-              <a:buNone/>
-            </a:pPr>
             <a:r>
               <a:rPr lang="en-US" sz="1300" dirty="0">
                 <a:solidFill>
@@ -3324,7 +3096,7 @@
             <a:endParaRPr lang="en-US" sz="1300" dirty="0"/>
           </a:p>
           <a:p>
-            <a:pPr indent="0" marL="0">
+            <a:pPr marL="0" indent="0">
               <a:buNone/>
             </a:pPr>
             <a:r>
@@ -3338,9 +3110,6 @@
               </a:rPr>
               <a:t>• Security Encapsulation:</a:t>
             </a:r>
-            <a:pPr indent="0" marL="0">
-              <a:buNone/>
-            </a:pPr>
             <a:r>
               <a:rPr lang="en-US" sz="1300" dirty="0">
                 <a:solidFill>
@@ -3355,7 +3124,7 @@
             <a:endParaRPr lang="en-US" sz="1300" dirty="0"/>
           </a:p>
           <a:p>
-            <a:pPr indent="0" marL="0">
+            <a:pPr marL="0" indent="0">
               <a:buNone/>
             </a:pPr>
             <a:r>
@@ -3369,9 +3138,6 @@
               </a:rPr>
               <a:t>• Name Resolution:</a:t>
             </a:r>
-            <a:pPr indent="0" marL="0">
-              <a:buNone/>
-            </a:pPr>
             <a:r>
               <a:rPr lang="en-US" sz="1300" dirty="0">
                 <a:solidFill>
@@ -3386,7 +3152,7 @@
             <a:endParaRPr lang="en-US" sz="1300" dirty="0"/>
           </a:p>
           <a:p>
-            <a:pPr indent="0" marL="0">
+            <a:pPr marL="0" indent="0">
               <a:buNone/>
             </a:pPr>
             <a:r>
@@ -3400,9 +3166,6 @@
               </a:rPr>
               <a:t>• Execution context:</a:t>
             </a:r>
-            <a:pPr indent="0" marL="0">
-              <a:buNone/>
-            </a:pPr>
             <a:r>
               <a:rPr lang="en-US" sz="1300" dirty="0">
                 <a:solidFill>
@@ -3466,7 +3229,7 @@
           <a:bodyPr wrap="square" lIns="0" tIns="0" rIns="0" bIns="0" rtlCol="0" anchor="ctr"/>
           <a:lstStyle/>
           <a:p>
-            <a:pPr indent="0" marL="0">
+            <a:pPr marL="0" indent="0">
               <a:buNone/>
             </a:pPr>
             <a:r>
@@ -3505,7 +3268,7 @@
           <a:bodyPr wrap="square" lIns="0" tIns="0" rIns="0" bIns="0" rtlCol="0" anchor="ctr"/>
           <a:lstStyle/>
           <a:p>
-            <a:pPr indent="0" marL="0">
+            <a:pPr marL="0" indent="0">
               <a:buNone/>
             </a:pPr>
             <a:r>
@@ -3519,9 +3282,6 @@
               </a:rPr>
               <a:t>• Dynamic Privileges:</a:t>
             </a:r>
-            <a:pPr indent="0" marL="0">
-              <a:buNone/>
-            </a:pPr>
             <a:r>
               <a:rPr lang="en-US" sz="1300" dirty="0">
                 <a:solidFill>
@@ -3536,7 +3296,7 @@
             <a:endParaRPr lang="en-US" sz="1300" dirty="0"/>
           </a:p>
           <a:p>
-            <a:pPr indent="0" marL="0">
+            <a:pPr marL="0" indent="0">
               <a:buNone/>
             </a:pPr>
             <a:r>
@@ -3550,9 +3310,6 @@
               </a:rPr>
               <a:t>• Name Resolution:</a:t>
             </a:r>
-            <a:pPr indent="0" marL="0">
-              <a:buNone/>
-            </a:pPr>
             <a:r>
               <a:rPr lang="en-US" sz="1300" dirty="0">
                 <a:solidFill>
@@ -3567,7 +3324,7 @@
             <a:endParaRPr lang="en-US" sz="1300" dirty="0"/>
           </a:p>
           <a:p>
-            <a:pPr indent="0" marL="0">
+            <a:pPr marL="0" indent="0">
               <a:buNone/>
             </a:pPr>
             <a:r>
@@ -3581,9 +3338,6 @@
               </a:rPr>
               <a:t>• Code sharing:</a:t>
             </a:r>
-            <a:pPr indent="0" marL="0">
-              <a:buNone/>
-            </a:pPr>
             <a:r>
               <a:rPr lang="en-US" sz="1300" dirty="0">
                 <a:solidFill>
@@ -3598,7 +3352,7 @@
             <a:endParaRPr lang="en-US" sz="1300" dirty="0"/>
           </a:p>
           <a:p>
-            <a:pPr indent="0" marL="0">
+            <a:pPr marL="0" indent="0">
               <a:buNone/>
             </a:pPr>
             <a:r>
@@ -3612,9 +3366,6 @@
               </a:rPr>
               <a:t>• Security constraint:</a:t>
             </a:r>
-            <a:pPr indent="0" marL="0">
-              <a:buNone/>
-            </a:pPr>
             <a:r>
               <a:rPr lang="en-US" sz="1300" dirty="0">
                 <a:solidFill>
@@ -3646,6 +3397,7 @@
         <a:solidFill>
           <a:srgbClr val="FFFFFF"/>
         </a:solidFill>
+        <a:effectLst/>
       </p:bgPr>
     </p:bg>
     <p:spTree>
@@ -3908,7 +3660,7 @@
           <a:bodyPr wrap="square" lIns="0" tIns="0" rIns="0" bIns="0" rtlCol="0" anchor="ctr"/>
           <a:lstStyle/>
           <a:p>
-            <a:pPr algn="ctr" indent="0" marL="0">
+            <a:pPr marL="0" indent="0" algn="ctr">
               <a:buNone/>
             </a:pPr>
             <a:r>
@@ -3928,14 +3680,14 @@
       </p:sp>
       <p:pic>
         <p:nvPicPr>
-          <p:cNvPr id="12" name="Image 0" descr="preencoded.png">    </p:cNvPr>
+          <p:cNvPr id="12" name="Image 0" descr="preencoded.png"/>
           <p:cNvPicPr>
             <a:picLocks noChangeAspect="1"/>
           </p:cNvPicPr>
           <p:nvPr/>
         </p:nvPicPr>
         <p:blipFill>
-          <a:blip r:embed="rId1"/>
+          <a:blip r:embed="rId3"/>
           <a:stretch>
             <a:fillRect/>
           </a:stretch>
@@ -3971,7 +3723,7 @@
           <a:bodyPr wrap="square" rtlCol="0" anchor="ctr"/>
           <a:lstStyle/>
           <a:p>
-            <a:pPr indent="0" marL="0">
+            <a:pPr marL="0" indent="0">
               <a:buNone/>
             </a:pPr>
             <a:r>
@@ -4035,7 +3787,7 @@
           <a:bodyPr wrap="square" rtlCol="0" anchor="ctr"/>
           <a:lstStyle/>
           <a:p>
-            <a:pPr indent="0" marL="0">
+            <a:pPr marL="0" indent="0">
               <a:buNone/>
             </a:pPr>
             <a:r>
@@ -4101,7 +3853,7 @@
           <a:bodyPr wrap="square" lIns="0" tIns="0" rIns="0" bIns="0" rtlCol="0" anchor="ctr"/>
           <a:lstStyle/>
           <a:p>
-            <a:pPr indent="0" marL="0">
+            <a:pPr marL="0" indent="0">
               <a:buNone/>
             </a:pPr>
             <a:r>
@@ -4140,7 +3892,7 @@
           <a:bodyPr wrap="square" lIns="0" tIns="0" rIns="0" bIns="0" rtlCol="0" anchor="ctr"/>
           <a:lstStyle/>
           <a:p>
-            <a:pPr indent="0" marL="0">
+            <a:pPr marL="0" indent="0">
               <a:buNone/>
             </a:pPr>
             <a:r>
@@ -4154,9 +3906,6 @@
               </a:rPr>
               <a:t>• Finding Packages:</a:t>
             </a:r>
-            <a:pPr indent="0" marL="0">
-              <a:buNone/>
-            </a:pPr>
             <a:r>
               <a:rPr lang="en-US" sz="1300" dirty="0">
                 <a:solidFill>
@@ -4171,7 +3920,7 @@
             <a:endParaRPr lang="en-US" sz="1300" dirty="0"/>
           </a:p>
           <a:p>
-            <a:pPr indent="0" marL="0">
+            <a:pPr marL="0" indent="0">
               <a:buNone/>
             </a:pPr>
             <a:r>
@@ -4188,7 +3937,7 @@
             <a:endParaRPr lang="en-US" sz="1300" dirty="0"/>
           </a:p>
           <a:p>
-            <a:pPr indent="0" marL="0">
+            <a:pPr marL="0" indent="0">
               <a:buNone/>
             </a:pPr>
             <a:r>
@@ -4202,9 +3951,6 @@
               </a:rPr>
               <a:t>• Status Monitoring:</a:t>
             </a:r>
-            <a:pPr indent="0" marL="0">
-              <a:buNone/>
-            </a:pPr>
             <a:r>
               <a:rPr lang="en-US" sz="1300" dirty="0">
                 <a:solidFill>
@@ -4219,7 +3965,7 @@
             <a:endParaRPr lang="en-US" sz="1300" dirty="0"/>
           </a:p>
           <a:p>
-            <a:pPr indent="0" marL="0">
+            <a:pPr marL="0" indent="0">
               <a:buNone/>
             </a:pPr>
             <a:r>
@@ -4233,9 +3979,6 @@
               </a:rPr>
               <a:t>• Describing Packages:</a:t>
             </a:r>
-            <a:pPr indent="0" marL="0">
-              <a:buNone/>
-            </a:pPr>
             <a:r>
               <a:rPr lang="en-US" sz="1300" dirty="0">
                 <a:solidFill>
@@ -4250,7 +3993,7 @@
             <a:endParaRPr lang="en-US" sz="1300" dirty="0"/>
           </a:p>
           <a:p>
-            <a:pPr indent="0" marL="0">
+            <a:pPr marL="0" indent="0">
               <a:buNone/>
             </a:pPr>
             <a:r>
@@ -4316,7 +4059,7 @@
           <a:bodyPr wrap="square" lIns="0" tIns="0" rIns="0" bIns="0" rtlCol="0" anchor="ctr"/>
           <a:lstStyle/>
           <a:p>
-            <a:pPr indent="0" marL="0">
+            <a:pPr marL="0" indent="0">
               <a:buNone/>
             </a:pPr>
             <a:r>
@@ -4355,7 +4098,7 @@
           <a:bodyPr wrap="square" lIns="0" tIns="0" rIns="0" bIns="0" rtlCol="0" anchor="ctr"/>
           <a:lstStyle/>
           <a:p>
-            <a:pPr indent="0" marL="0">
+            <a:pPr marL="0" indent="0">
               <a:buNone/>
             </a:pPr>
             <a:r>
@@ -4372,7 +4115,7 @@
             <a:endParaRPr lang="en-US" sz="1250" dirty="0"/>
           </a:p>
           <a:p>
-            <a:pPr indent="0" marL="0">
+            <a:pPr marL="0" indent="0">
               <a:buNone/>
             </a:pPr>
             <a:r>
@@ -4386,9 +4129,6 @@
               </a:rPr>
               <a:t>1. Timestamp Method (Default):</a:t>
             </a:r>
-            <a:pPr indent="0" marL="0">
-              <a:buNone/>
-            </a:pPr>
             <a:r>
               <a:rPr lang="en-US" sz="1250" dirty="0">
                 <a:solidFill>
@@ -4403,7 +4143,7 @@
             <a:endParaRPr lang="en-US" sz="1250" dirty="0"/>
           </a:p>
           <a:p>
-            <a:pPr indent="0" marL="0">
+            <a:pPr marL="0" indent="0">
               <a:buNone/>
             </a:pPr>
             <a:r>
@@ -4417,9 +4157,6 @@
               </a:rPr>
               <a:t>2. Signature Method:</a:t>
             </a:r>
-            <a:pPr indent="0" marL="0">
-              <a:buNone/>
-            </a:pPr>
             <a:r>
               <a:rPr lang="en-US" sz="1250" dirty="0">
                 <a:solidFill>
@@ -4451,6 +4188,7 @@
         <a:solidFill>
           <a:srgbClr val="FFFFFF"/>
         </a:solidFill>
+        <a:effectLst/>
       </p:bgPr>
     </p:bg>
     <p:spTree>
@@ -4713,7 +4451,7 @@
           <a:bodyPr wrap="square" lIns="0" tIns="0" rIns="0" bIns="0" rtlCol="0" anchor="ctr"/>
           <a:lstStyle/>
           <a:p>
-            <a:pPr algn="ctr" indent="0" marL="0">
+            <a:pPr marL="0" indent="0" algn="ctr">
               <a:buNone/>
             </a:pPr>
             <a:r>
@@ -4733,14 +4471,14 @@
       </p:sp>
       <p:pic>
         <p:nvPicPr>
-          <p:cNvPr id="12" name="Image 0" descr="preencoded.png">    </p:cNvPr>
+          <p:cNvPr id="12" name="Image 0" descr="preencoded.png"/>
           <p:cNvPicPr>
             <a:picLocks noChangeAspect="1"/>
           </p:cNvPicPr>
           <p:nvPr/>
         </p:nvPicPr>
         <p:blipFill>
-          <a:blip r:embed="rId1"/>
+          <a:blip r:embed="rId3"/>
           <a:stretch>
             <a:fillRect/>
           </a:stretch>
@@ -4776,7 +4514,7 @@
           <a:bodyPr wrap="square" rtlCol="0" anchor="ctr"/>
           <a:lstStyle/>
           <a:p>
-            <a:pPr indent="0" marL="0">
+            <a:pPr marL="0" indent="0">
               <a:buNone/>
             </a:pPr>
             <a:r>
@@ -4840,7 +4578,7 @@
           <a:bodyPr wrap="square" rtlCol="0" anchor="ctr"/>
           <a:lstStyle/>
           <a:p>
-            <a:pPr indent="0" marL="0">
+            <a:pPr marL="0" indent="0">
               <a:buNone/>
             </a:pPr>
             <a:r>
@@ -4906,7 +4644,7 @@
           <a:bodyPr wrap="square" lIns="0" tIns="0" rIns="0" bIns="0" rtlCol="0" anchor="ctr"/>
           <a:lstStyle/>
           <a:p>
-            <a:pPr indent="0" marL="0">
+            <a:pPr marL="0" indent="0">
               <a:buNone/>
             </a:pPr>
             <a:r>
@@ -4945,7 +4683,7 @@
           <a:bodyPr wrap="square" lIns="0" tIns="0" rIns="0" bIns="0" rtlCol="0" anchor="ctr"/>
           <a:lstStyle/>
           <a:p>
-            <a:pPr indent="0" marL="0">
+            <a:pPr marL="0" indent="0">
               <a:buNone/>
             </a:pPr>
             <a:r>
@@ -5011,7 +4749,7 @@
           <a:bodyPr wrap="square" lIns="0" tIns="0" rIns="0" bIns="0" rtlCol="0" anchor="ctr"/>
           <a:lstStyle/>
           <a:p>
-            <a:pPr indent="0" marL="0">
+            <a:pPr marL="0" indent="0">
               <a:buNone/>
             </a:pPr>
             <a:r>
@@ -5050,7 +4788,7 @@
           <a:bodyPr wrap="square" lIns="0" tIns="0" rIns="0" bIns="0" rtlCol="0" anchor="ctr"/>
           <a:lstStyle/>
           <a:p>
-            <a:pPr indent="0" marL="0">
+            <a:pPr marL="0" indent="0">
               <a:buNone/>
             </a:pPr>
             <a:r>
@@ -5116,7 +4854,7 @@
           <a:bodyPr wrap="square" lIns="0" tIns="0" rIns="0" bIns="0" rtlCol="0" anchor="ctr"/>
           <a:lstStyle/>
           <a:p>
-            <a:pPr indent="0" marL="0">
+            <a:pPr marL="0" indent="0">
               <a:buNone/>
             </a:pPr>
             <a:r>
@@ -5155,7 +4893,7 @@
           <a:bodyPr wrap="square" lIns="0" tIns="0" rIns="0" bIns="0" rtlCol="0" anchor="ctr"/>
           <a:lstStyle/>
           <a:p>
-            <a:pPr indent="0" marL="0">
+            <a:pPr marL="0" indent="0">
               <a:buNone/>
             </a:pPr>
             <a:r>
@@ -5221,7 +4959,7 @@
           <a:bodyPr wrap="square" lIns="0" tIns="0" rIns="0" bIns="0" rtlCol="0" anchor="ctr"/>
           <a:lstStyle/>
           <a:p>
-            <a:pPr indent="0" marL="0">
+            <a:pPr marL="0" indent="0">
               <a:buNone/>
             </a:pPr>
             <a:r>
@@ -5260,7 +4998,7 @@
           <a:bodyPr wrap="square" lIns="0" tIns="0" rIns="0" bIns="0" rtlCol="0" anchor="ctr"/>
           <a:lstStyle/>
           <a:p>
-            <a:pPr indent="0" marL="0">
+            <a:pPr marL="0" indent="0">
               <a:buNone/>
             </a:pPr>
             <a:r>
@@ -5294,6 +5032,7 @@
         <a:solidFill>
           <a:srgbClr val="FFFFFF"/>
         </a:solidFill>
+        <a:effectLst/>
       </p:bgPr>
     </p:bg>
     <p:spTree>
@@ -5556,7 +5295,7 @@
           <a:bodyPr wrap="square" lIns="0" tIns="0" rIns="0" bIns="0" rtlCol="0" anchor="ctr"/>
           <a:lstStyle/>
           <a:p>
-            <a:pPr algn="ctr" indent="0" marL="0">
+            <a:pPr marL="0" indent="0" algn="ctr">
               <a:buNone/>
             </a:pPr>
             <a:r>
@@ -5576,14 +5315,14 @@
       </p:sp>
       <p:pic>
         <p:nvPicPr>
-          <p:cNvPr id="12" name="Image 0" descr="preencoded.png">    </p:cNvPr>
+          <p:cNvPr id="12" name="Image 0" descr="preencoded.png"/>
           <p:cNvPicPr>
             <a:picLocks noChangeAspect="1"/>
           </p:cNvPicPr>
           <p:nvPr/>
         </p:nvPicPr>
         <p:blipFill>
-          <a:blip r:embed="rId1"/>
+          <a:blip r:embed="rId3"/>
           <a:stretch>
             <a:fillRect/>
           </a:stretch>
@@ -5619,7 +5358,7 @@
           <a:bodyPr wrap="square" rtlCol="0" anchor="ctr"/>
           <a:lstStyle/>
           <a:p>
-            <a:pPr algn="ctr" indent="0" marL="0">
+            <a:pPr marL="0" indent="0" algn="ctr">
               <a:buNone/>
             </a:pPr>
             <a:r>
@@ -5658,7 +5397,7 @@
           <a:bodyPr wrap="square" rtlCol="0" anchor="ctr"/>
           <a:lstStyle/>
           <a:p>
-            <a:pPr algn="ctr" indent="0" marL="0">
+            <a:pPr marL="0" indent="0" algn="ctr">
               <a:buNone/>
             </a:pPr>
             <a:r>
@@ -5675,7 +5414,7 @@
             <a:endParaRPr lang="en-US" sz="1300" dirty="0"/>
           </a:p>
           <a:p>
-            <a:pPr algn="ctr" indent="0" marL="0">
+            <a:pPr marL="0" indent="0" algn="ctr">
               <a:buNone/>
             </a:pPr>
             <a:r>
@@ -5994,4 +5733,299 @@
     </a:ext>
   </a:extLst>
 </a:theme>
+</file>
+
+<file path=ppt/theme/theme2.xml><?xml version="1.0" encoding="utf-8"?>
+<a:theme xmlns:a="http://schemas.openxmlformats.org/drawingml/2006/main" name="Office Theme">
+  <a:themeElements>
+    <a:clrScheme name="Office">
+      <a:dk1>
+        <a:sysClr val="windowText" lastClr="000000"/>
+      </a:dk1>
+      <a:lt1>
+        <a:sysClr val="window" lastClr="FFFFFF"/>
+      </a:lt1>
+      <a:dk2>
+        <a:srgbClr val="44546A"/>
+      </a:dk2>
+      <a:lt2>
+        <a:srgbClr val="E7E6E6"/>
+      </a:lt2>
+      <a:accent1>
+        <a:srgbClr val="4472C4"/>
+      </a:accent1>
+      <a:accent2>
+        <a:srgbClr val="ED7D31"/>
+      </a:accent2>
+      <a:accent3>
+        <a:srgbClr val="A5A5A5"/>
+      </a:accent3>
+      <a:accent4>
+        <a:srgbClr val="FFC000"/>
+      </a:accent4>
+      <a:accent5>
+        <a:srgbClr val="5B9BD5"/>
+      </a:accent5>
+      <a:accent6>
+        <a:srgbClr val="70AD47"/>
+      </a:accent6>
+      <a:hlink>
+        <a:srgbClr val="0563C1"/>
+      </a:hlink>
+      <a:folHlink>
+        <a:srgbClr val="954F72"/>
+      </a:folHlink>
+    </a:clrScheme>
+    <a:fontScheme name="Office">
+      <a:majorFont>
+        <a:latin typeface="Calibri Light" panose="020F0302020204030204"/>
+        <a:ea typeface=""/>
+        <a:cs typeface=""/>
+        <a:font script="Jpan" typeface="游ゴシック Light"/>
+        <a:font script="Hang" typeface="맑은 고딕"/>
+        <a:font script="Hans" typeface="等线 Light"/>
+        <a:font script="Hant" typeface="新細明體"/>
+        <a:font script="Arab" typeface="Times New Roman"/>
+        <a:font script="Hebr" typeface="Times New Roman"/>
+        <a:font script="Thai" typeface="Angsana New"/>
+        <a:font script="Ethi" typeface="Nyala"/>
+        <a:font script="Beng" typeface="Vrinda"/>
+        <a:font script="Gujr" typeface="Shruti"/>
+        <a:font script="Khmr" typeface="MoolBoran"/>
+        <a:font script="Knda" typeface="Tunga"/>
+        <a:font script="Guru" typeface="Raavi"/>
+        <a:font script="Cans" typeface="Euphemia"/>
+        <a:font script="Cher" typeface="Plantagenet Cherokee"/>
+        <a:font script="Yiii" typeface="Microsoft Yi Baiti"/>
+        <a:font script="Tibt" typeface="Microsoft Himalaya"/>
+        <a:font script="Thaa" typeface="MV Boli"/>
+        <a:font script="Deva" typeface="Mangal"/>
+        <a:font script="Telu" typeface="Gautami"/>
+        <a:font script="Taml" typeface="Latha"/>
+        <a:font script="Syrc" typeface="Estrangelo Edessa"/>
+        <a:font script="Orya" typeface="Kalinga"/>
+        <a:font script="Mlym" typeface="Kartika"/>
+        <a:font script="Laoo" typeface="DokChampa"/>
+        <a:font script="Sinh" typeface="Iskoola Pota"/>
+        <a:font script="Mong" typeface="Mongolian Baiti"/>
+        <a:font script="Viet" typeface="Times New Roman"/>
+        <a:font script="Uigh" typeface="Microsoft Uighur"/>
+        <a:font script="Geor" typeface="Sylfaen"/>
+        <a:font script="Armn" typeface="Arial"/>
+        <a:font script="Bugi" typeface="Leelawadee UI"/>
+        <a:font script="Bopo" typeface="Microsoft JhengHei"/>
+        <a:font script="Java" typeface="Javanese Text"/>
+        <a:font script="Lisu" typeface="Segoe UI"/>
+        <a:font script="Mymr" typeface="Myanmar Text"/>
+        <a:font script="Nkoo" typeface="Ebrima"/>
+        <a:font script="Olck" typeface="Nirmala UI"/>
+        <a:font script="Osma" typeface="Ebrima"/>
+        <a:font script="Phag" typeface="Phagspa"/>
+        <a:font script="Syrn" typeface="Estrangelo Edessa"/>
+        <a:font script="Syrj" typeface="Estrangelo Edessa"/>
+        <a:font script="Syre" typeface="Estrangelo Edessa"/>
+        <a:font script="Sora" typeface="Nirmala UI"/>
+        <a:font script="Tale" typeface="Microsoft Tai Le"/>
+        <a:font script="Talu" typeface="Microsoft New Tai Lue"/>
+        <a:font script="Tfng" typeface="Ebrima"/>
+      </a:majorFont>
+      <a:minorFont>
+        <a:latin typeface="Calibri" panose="020F0502020204030204"/>
+        <a:ea typeface=""/>
+        <a:cs typeface=""/>
+        <a:font script="Jpan" typeface="游ゴシック"/>
+        <a:font script="Hang" typeface="맑은 고딕"/>
+        <a:font script="Hans" typeface="等线"/>
+        <a:font script="Hant" typeface="新細明體"/>
+        <a:font script="Arab" typeface="Arial"/>
+        <a:font script="Hebr" typeface="Arial"/>
+        <a:font script="Thai" typeface="Cordia New"/>
+        <a:font script="Ethi" typeface="Nyala"/>
+        <a:font script="Beng" typeface="Vrinda"/>
+        <a:font script="Gujr" typeface="Shruti"/>
+        <a:font script="Khmr" typeface="DaunPenh"/>
+        <a:font script="Knda" typeface="Tunga"/>
+        <a:font script="Guru" typeface="Raavi"/>
+        <a:font script="Cans" typeface="Euphemia"/>
+        <a:font script="Cher" typeface="Plantagenet Cherokee"/>
+        <a:font script="Yiii" typeface="Microsoft Yi Baiti"/>
+        <a:font script="Tibt" typeface="Microsoft Himalaya"/>
+        <a:font script="Thaa" typeface="MV Boli"/>
+        <a:font script="Deva" typeface="Mangal"/>
+        <a:font script="Telu" typeface="Gautami"/>
+        <a:font script="Taml" typeface="Latha"/>
+        <a:font script="Syrc" typeface="Estrangelo Edessa"/>
+        <a:font script="Orya" typeface="Kalinga"/>
+        <a:font script="Mlym" typeface="Kartika"/>
+        <a:font script="Laoo" typeface="DokChampa"/>
+        <a:font script="Sinh" typeface="Iskoola Pota"/>
+        <a:font script="Mong" typeface="Mongolian Baiti"/>
+        <a:font script="Viet" typeface="Arial"/>
+        <a:font script="Uigh" typeface="Microsoft Uighur"/>
+        <a:font script="Geor" typeface="Sylfaen"/>
+        <a:font script="Armn" typeface="Arial"/>
+        <a:font script="Bugi" typeface="Leelawadee UI"/>
+        <a:font script="Bopo" typeface="Microsoft JhengHei"/>
+        <a:font script="Java" typeface="Javanese Text"/>
+        <a:font script="Lisu" typeface="Segoe UI"/>
+        <a:font script="Mymr" typeface="Myanmar Text"/>
+        <a:font script="Nkoo" typeface="Ebrima"/>
+        <a:font script="Olck" typeface="Nirmala UI"/>
+        <a:font script="Osma" typeface="Ebrima"/>
+        <a:font script="Phag" typeface="Phagspa"/>
+        <a:font script="Syrn" typeface="Estrangelo Edessa"/>
+        <a:font script="Syrj" typeface="Estrangelo Edessa"/>
+        <a:font script="Syre" typeface="Estrangelo Edessa"/>
+        <a:font script="Sora" typeface="Nirmala UI"/>
+        <a:font script="Tale" typeface="Microsoft Tai Le"/>
+        <a:font script="Talu" typeface="Microsoft New Tai Lue"/>
+        <a:font script="Tfng" typeface="Ebrima"/>
+      </a:minorFont>
+    </a:fontScheme>
+    <a:fmtScheme name="Office">
+      <a:fillStyleLst>
+        <a:solidFill>
+          <a:schemeClr val="phClr"/>
+        </a:solidFill>
+        <a:gradFill rotWithShape="1">
+          <a:gsLst>
+            <a:gs pos="0">
+              <a:schemeClr val="phClr">
+                <a:lumMod val="110000"/>
+                <a:satMod val="105000"/>
+                <a:tint val="67000"/>
+              </a:schemeClr>
+            </a:gs>
+            <a:gs pos="50000">
+              <a:schemeClr val="phClr">
+                <a:lumMod val="105000"/>
+                <a:satMod val="103000"/>
+                <a:tint val="73000"/>
+              </a:schemeClr>
+            </a:gs>
+            <a:gs pos="100000">
+              <a:schemeClr val="phClr">
+                <a:lumMod val="105000"/>
+                <a:satMod val="109000"/>
+                <a:tint val="81000"/>
+              </a:schemeClr>
+            </a:gs>
+          </a:gsLst>
+          <a:lin ang="5400000" scaled="0"/>
+        </a:gradFill>
+        <a:gradFill rotWithShape="1">
+          <a:gsLst>
+            <a:gs pos="0">
+              <a:schemeClr val="phClr">
+                <a:satMod val="103000"/>
+                <a:lumMod val="102000"/>
+                <a:tint val="94000"/>
+              </a:schemeClr>
+            </a:gs>
+            <a:gs pos="50000">
+              <a:schemeClr val="phClr">
+                <a:satMod val="110000"/>
+                <a:lumMod val="100000"/>
+                <a:shade val="100000"/>
+              </a:schemeClr>
+            </a:gs>
+            <a:gs pos="100000">
+              <a:schemeClr val="phClr">
+                <a:lumMod val="99000"/>
+                <a:satMod val="120000"/>
+                <a:shade val="78000"/>
+              </a:schemeClr>
+            </a:gs>
+          </a:gsLst>
+          <a:lin ang="5400000" scaled="0"/>
+        </a:gradFill>
+      </a:fillStyleLst>
+      <a:lnStyleLst>
+        <a:ln w="6350" cap="flat" cmpd="sng" algn="ctr">
+          <a:solidFill>
+            <a:schemeClr val="phClr"/>
+          </a:solidFill>
+          <a:prstDash val="solid"/>
+          <a:miter lim="800000"/>
+        </a:ln>
+        <a:ln w="12700" cap="flat" cmpd="sng" algn="ctr">
+          <a:solidFill>
+            <a:schemeClr val="phClr"/>
+          </a:solidFill>
+          <a:prstDash val="solid"/>
+          <a:miter lim="800000"/>
+        </a:ln>
+        <a:ln w="19050" cap="flat" cmpd="sng" algn="ctr">
+          <a:solidFill>
+            <a:schemeClr val="phClr"/>
+          </a:solidFill>
+          <a:prstDash val="solid"/>
+          <a:miter lim="800000"/>
+        </a:ln>
+      </a:lnStyleLst>
+      <a:effectStyleLst>
+        <a:effectStyle>
+          <a:effectLst/>
+        </a:effectStyle>
+        <a:effectStyle>
+          <a:effectLst/>
+        </a:effectStyle>
+        <a:effectStyle>
+          <a:effectLst>
+            <a:outerShdw blurRad="57150" dist="19050" dir="5400000" algn="ctr" rotWithShape="0">
+              <a:srgbClr val="000000">
+                <a:alpha val="63000"/>
+              </a:srgbClr>
+            </a:outerShdw>
+          </a:effectLst>
+        </a:effectStyle>
+      </a:effectStyleLst>
+      <a:bgFillStyleLst>
+        <a:solidFill>
+          <a:schemeClr val="phClr"/>
+        </a:solidFill>
+        <a:solidFill>
+          <a:schemeClr val="phClr">
+            <a:tint val="95000"/>
+            <a:satMod val="170000"/>
+          </a:schemeClr>
+        </a:solidFill>
+        <a:gradFill rotWithShape="1">
+          <a:gsLst>
+            <a:gs pos="0">
+              <a:schemeClr val="phClr">
+                <a:tint val="93000"/>
+                <a:satMod val="150000"/>
+                <a:shade val="98000"/>
+                <a:lumMod val="102000"/>
+              </a:schemeClr>
+            </a:gs>
+            <a:gs pos="50000">
+              <a:schemeClr val="phClr">
+                <a:tint val="98000"/>
+                <a:satMod val="130000"/>
+                <a:shade val="90000"/>
+                <a:lumMod val="103000"/>
+              </a:schemeClr>
+            </a:gs>
+            <a:gs pos="100000">
+              <a:schemeClr val="phClr">
+                <a:shade val="63000"/>
+                <a:satMod val="120000"/>
+              </a:schemeClr>
+            </a:gs>
+          </a:gsLst>
+          <a:lin ang="5400000" scaled="0"/>
+        </a:gradFill>
+      </a:bgFillStyleLst>
+    </a:fmtScheme>
+  </a:themeElements>
+  <a:objectDefaults/>
+  <a:extraClrSchemeLst/>
+  <a:extLst>
+    <a:ext uri="{05A4C25C-085E-4340-85A3-A5531E510DB2}">
+      <thm15:themeFamily xmlns:thm15="http://schemas.microsoft.com/office/thememl/2012/main" name="Office Theme" id="{62F939B6-93AF-4DB8-9C6B-D6C7DFDC589F}" vid="{4A3C46E8-61CC-4603-A589-7422A47A8E4A}"/>
+    </a:ext>
+  </a:extLst>
+</a:theme>
 </file>
</xml_diff>